<commit_message>
add encoder LEFT SW
</commit_message>
<xml_diff>
--- a/Activityboard.pptx
+++ b/Activityboard.pptx
@@ -17756,7 +17756,7 @@
           <p:nvPr>
             <p:extLst>
               <p:ext uri="{D42A27DB-BD31-4B8C-83A1-F6EECF244321}">
-                <p14:modId xmlns:p14="http://schemas.microsoft.com/office/powerpoint/2010/main" val="324218789"/>
+                <p14:modId xmlns:p14="http://schemas.microsoft.com/office/powerpoint/2010/main" val="2626316262"/>
               </p:ext>
             </p:extLst>
           </p:nvPr>
@@ -17917,7 +17917,7 @@
                       <a:pPr algn="r"/>
                       <a:r>
                         <a:rPr lang="de-DE" sz="1400"/>
-                        <a:t>Rotary</a:t>
+                        <a:t>Wake</a:t>
                       </a:r>
                     </a:p>
                   </a:txBody>
@@ -18693,7 +18693,35 @@
                     <a:bodyPr/>
                     <a:lstStyle/>
                     <a:p>
-                      <a:endParaRPr lang="de-DE" sz="1400"/>
+                      <a:pPr marL="0" marR="0" lvl="0" indent="0" algn="l" defTabSz="914400" rtl="0" eaLnBrk="1" fontAlgn="auto" latinLnBrk="0" hangingPunct="1">
+                        <a:lnSpc>
+                          <a:spcPct val="100000"/>
+                        </a:lnSpc>
+                        <a:spcBef>
+                          <a:spcPts val="0"/>
+                        </a:spcBef>
+                        <a:spcAft>
+                          <a:spcPts val="0"/>
+                        </a:spcAft>
+                        <a:buClrTx/>
+                        <a:buSzTx/>
+                        <a:buFontTx/>
+                        <a:buNone/>
+                        <a:tabLst/>
+                        <a:defRPr/>
+                      </a:pPr>
+                      <a:r>
+                        <a:rPr lang="de-DE" sz="1400"/>
+                        <a:t>CLK-1 (10 k</a:t>
+                      </a:r>
+                      <a:r>
+                        <a:rPr lang="el-GR" sz="1400"/>
+                        <a:t>Ω</a:t>
+                      </a:r>
+                      <a:r>
+                        <a:rPr lang="de-DE" sz="1400"/>
+                        <a:t>)</a:t>
+                      </a:r>
                     </a:p>
                   </a:txBody>
                   <a:tcPr/>
@@ -18814,9 +18842,26 @@
                     <a:bodyPr/>
                     <a:lstStyle/>
                     <a:p>
+                      <a:pPr marL="0" marR="0" lvl="0" indent="0" algn="l" defTabSz="914400" rtl="0" eaLnBrk="1" fontAlgn="auto" latinLnBrk="0" hangingPunct="1">
+                        <a:lnSpc>
+                          <a:spcPct val="100000"/>
+                        </a:lnSpc>
+                        <a:spcBef>
+                          <a:spcPts val="0"/>
+                        </a:spcBef>
+                        <a:spcAft>
+                          <a:spcPts val="0"/>
+                        </a:spcAft>
+                        <a:buClrTx/>
+                        <a:buSzTx/>
+                        <a:buFontTx/>
+                        <a:buNone/>
+                        <a:tabLst/>
+                        <a:defRPr/>
+                      </a:pPr>
                       <a:r>
                         <a:rPr lang="de-DE" sz="1400"/>
-                        <a:t>CLK-1</a:t>
+                        <a:t>DT-1</a:t>
                       </a:r>
                     </a:p>
                   </a:txBody>
@@ -18937,7 +18982,7 @@
                     <a:p>
                       <a:r>
                         <a:rPr lang="de-DE" sz="1400"/>
-                        <a:t>DT-1</a:t>
+                        <a:t>SW-1</a:t>
                       </a:r>
                     </a:p>
                   </a:txBody>
@@ -19560,7 +19605,10 @@
                     <a:lstStyle/>
                     <a:p>
                       <a:pPr algn="r"/>
-                      <a:endParaRPr lang="de-DE" sz="1400"/>
+                      <a:r>
+                        <a:rPr lang="de-DE" sz="1400"/>
+                        <a:t>XX</a:t>
+                      </a:r>
                     </a:p>
                   </a:txBody>
                   <a:tcPr/>
@@ -21713,14 +21761,14 @@
           <p:nvPr>
             <p:extLst>
               <p:ext uri="{D42A27DB-BD31-4B8C-83A1-F6EECF244321}">
-                <p14:modId xmlns:p14="http://schemas.microsoft.com/office/powerpoint/2010/main" val="52895758"/>
+                <p14:modId xmlns:p14="http://schemas.microsoft.com/office/powerpoint/2010/main" val="828006962"/>
               </p:ext>
             </p:extLst>
           </p:nvPr>
         </p:nvGraphicFramePr>
         <p:xfrm>
           <a:off x="1558060" y="9525"/>
-          <a:ext cx="5519015" cy="6848470"/>
+          <a:ext cx="5519015" cy="6848485"/>
         </p:xfrm>
         <a:graphic>
           <a:graphicData uri="http://schemas.openxmlformats.org/drawingml/2006/table">
@@ -21758,7 +21806,7 @@
                   </a:extLst>
                 </a:gridCol>
               </a:tblGrid>
-              <a:tr h="226758">
+              <a:tr h="219491">
                 <a:tc>
                   <a:txBody>
                     <a:bodyPr/>
@@ -21879,7 +21927,7 @@
                   </a:ext>
                 </a:extLst>
               </a:tr>
-              <a:tr h="226758">
+              <a:tr h="219491">
                 <a:tc>
                   <a:txBody>
                     <a:bodyPr/>
@@ -22000,7 +22048,7 @@
                   </a:ext>
                 </a:extLst>
               </a:tr>
-              <a:tr h="226758">
+              <a:tr h="219491">
                 <a:tc>
                   <a:txBody>
                     <a:bodyPr/>
@@ -22121,7 +22169,7 @@
                   </a:ext>
                 </a:extLst>
               </a:tr>
-              <a:tr h="226758">
+              <a:tr h="219491">
                 <a:tc>
                   <a:txBody>
                     <a:bodyPr/>
@@ -22242,7 +22290,7 @@
                   </a:ext>
                 </a:extLst>
               </a:tr>
-              <a:tr h="226758">
+              <a:tr h="219491">
                 <a:tc>
                   <a:txBody>
                     <a:bodyPr/>
@@ -22363,7 +22411,7 @@
                   </a:ext>
                 </a:extLst>
               </a:tr>
-              <a:tr h="226758">
+              <a:tr h="219491">
                 <a:tc>
                   <a:txBody>
                     <a:bodyPr/>
@@ -22484,7 +22532,7 @@
                   </a:ext>
                 </a:extLst>
               </a:tr>
-              <a:tr h="226758">
+              <a:tr h="219491">
                 <a:tc>
                   <a:txBody>
                     <a:bodyPr/>
@@ -22605,7 +22653,7 @@
                   </a:ext>
                 </a:extLst>
               </a:tr>
-              <a:tr h="226758">
+              <a:tr h="219491">
                 <a:tc>
                   <a:txBody>
                     <a:bodyPr/>
@@ -22732,7 +22780,7 @@
                   </a:ext>
                 </a:extLst>
               </a:tr>
-              <a:tr h="226758">
+              <a:tr h="219491">
                 <a:tc>
                   <a:txBody>
                     <a:bodyPr/>
@@ -22859,7 +22907,7 @@
                   </a:ext>
                 </a:extLst>
               </a:tr>
-              <a:tr h="226758">
+              <a:tr h="219491">
                 <a:tc>
                   <a:txBody>
                     <a:bodyPr/>
@@ -22986,7 +23034,7 @@
                   </a:ext>
                 </a:extLst>
               </a:tr>
-              <a:tr h="226758">
+              <a:tr h="219491">
                 <a:tc>
                   <a:txBody>
                     <a:bodyPr/>
@@ -23113,7 +23161,7 @@
                   </a:ext>
                 </a:extLst>
               </a:tr>
-              <a:tr h="226758">
+              <a:tr h="219491">
                 <a:tc>
                   <a:txBody>
                     <a:bodyPr/>
@@ -23240,7 +23288,7 @@
                   </a:ext>
                 </a:extLst>
               </a:tr>
-              <a:tr h="226758">
+              <a:tr h="219491">
                 <a:tc>
                   <a:txBody>
                     <a:bodyPr/>
@@ -23367,7 +23415,7 @@
                   </a:ext>
                 </a:extLst>
               </a:tr>
-              <a:tr h="226758">
+              <a:tr h="219491">
                 <a:tc>
                   <a:txBody>
                     <a:bodyPr/>
@@ -23494,7 +23542,7 @@
                   </a:ext>
                 </a:extLst>
               </a:tr>
-              <a:tr h="226758">
+              <a:tr h="219491">
                 <a:tc>
                   <a:txBody>
                     <a:bodyPr/>
@@ -23621,7 +23669,7 @@
                   </a:ext>
                 </a:extLst>
               </a:tr>
-              <a:tr h="226758">
+              <a:tr h="219491">
                 <a:tc>
                   <a:txBody>
                     <a:bodyPr/>
@@ -23742,7 +23790,7 @@
                   </a:ext>
                 </a:extLst>
               </a:tr>
-              <a:tr h="226758">
+              <a:tr h="219491">
                 <a:tc>
                   <a:txBody>
                     <a:bodyPr/>
@@ -23863,7 +23911,7 @@
                   </a:ext>
                 </a:extLst>
               </a:tr>
-              <a:tr h="226758">
+              <a:tr h="219491">
                 <a:tc>
                   <a:txBody>
                     <a:bodyPr/>
@@ -23984,7 +24032,7 @@
                   </a:ext>
                 </a:extLst>
               </a:tr>
-              <a:tr h="226758">
+              <a:tr h="219491">
                 <a:tc>
                   <a:txBody>
                     <a:bodyPr/>
@@ -24105,7 +24153,7 @@
                   </a:ext>
                 </a:extLst>
               </a:tr>
-              <a:tr h="226758">
+              <a:tr h="219491">
                 <a:tc>
                   <a:txBody>
                     <a:bodyPr/>
@@ -24226,7 +24274,7 @@
                   </a:ext>
                 </a:extLst>
               </a:tr>
-              <a:tr h="226758">
+              <a:tr h="219491">
                 <a:tc>
                   <a:txBody>
                     <a:bodyPr/>
@@ -24347,7 +24395,7 @@
                   </a:ext>
                 </a:extLst>
               </a:tr>
-              <a:tr h="226758">
+              <a:tr h="219491">
                 <a:tc>
                   <a:txBody>
                     <a:bodyPr/>
@@ -24468,7 +24516,7 @@
                   </a:ext>
                 </a:extLst>
               </a:tr>
-              <a:tr h="226758">
+              <a:tr h="219491">
                 <a:tc>
                   <a:txBody>
                     <a:bodyPr/>
@@ -24589,7 +24637,7 @@
                   </a:ext>
                 </a:extLst>
               </a:tr>
-              <a:tr h="272488">
+              <a:tr h="263755">
                 <a:tc>
                   <a:txBody>
                     <a:bodyPr/>
@@ -24709,7 +24757,7 @@
                   </a:ext>
                 </a:extLst>
               </a:tr>
-              <a:tr h="226758">
+              <a:tr h="219491">
                 <a:tc>
                   <a:txBody>
                     <a:bodyPr/>
@@ -24848,7 +24896,7 @@
                   </a:ext>
                 </a:extLst>
               </a:tr>
-              <a:tr h="226758">
+              <a:tr h="219491">
                 <a:tc>
                   <a:txBody>
                     <a:bodyPr/>
@@ -24921,7 +24969,7 @@
                           <a:effectLst/>
                           <a:latin typeface="Calibri" panose="020F0502020204030204" pitchFamily="34" charset="0"/>
                         </a:rPr>
-                        <a:t>GPIO 32</a:t>
+                        <a:t>GPIO 35</a:t>
                       </a:r>
                     </a:p>
                   </a:txBody>
@@ -24960,7 +25008,7 @@
                   </a:ext>
                 </a:extLst>
               </a:tr>
-              <a:tr h="226758">
+              <a:tr h="219491">
                 <a:tc>
                   <a:txBody>
                     <a:bodyPr/>
@@ -25033,7 +25081,7 @@
                           <a:effectLst/>
                           <a:latin typeface="Calibri" panose="020F0502020204030204" pitchFamily="34" charset="0"/>
                         </a:rPr>
-                        <a:t>GPIO 33</a:t>
+                        <a:t>GPIO 32</a:t>
                       </a:r>
                     </a:p>
                   </a:txBody>
@@ -25072,7 +25120,128 @@
                   </a:ext>
                 </a:extLst>
               </a:tr>
-              <a:tr h="226758">
+              <a:tr h="219491">
+                <a:tc>
+                  <a:txBody>
+                    <a:bodyPr/>
+                    <a:lstStyle/>
+                    <a:p>
+                      <a:pPr marL="108000" algn="l" fontAlgn="b">
+                        <a:spcBef>
+                          <a:spcPts val="0"/>
+                        </a:spcBef>
+                        <a:spcAft>
+                          <a:spcPts val="0"/>
+                        </a:spcAft>
+                      </a:pPr>
+                      <a:endParaRPr lang="de-DE" sz="900" b="0" i="0" u="none" strike="noStrike">
+                        <a:solidFill>
+                          <a:srgbClr val="000000"/>
+                        </a:solidFill>
+                        <a:effectLst/>
+                        <a:latin typeface="Calibri" panose="020F0502020204030204" pitchFamily="34" charset="0"/>
+                      </a:endParaRPr>
+                    </a:p>
+                  </a:txBody>
+                  <a:tcPr marL="7002" marR="7002" marT="0" marB="0" anchor="b"/>
+                </a:tc>
+                <a:tc>
+                  <a:txBody>
+                    <a:bodyPr/>
+                    <a:lstStyle/>
+                    <a:p>
+                      <a:pPr marL="108000" algn="l" rtl="0" fontAlgn="ctr">
+                        <a:spcBef>
+                          <a:spcPts val="0"/>
+                        </a:spcBef>
+                        <a:spcAft>
+                          <a:spcPts val="0"/>
+                        </a:spcAft>
+                      </a:pPr>
+                      <a:r>
+                        <a:rPr lang="de-DE" sz="900" b="0" i="0" u="none" strike="noStrike">
+                          <a:solidFill>
+                            <a:srgbClr val="000000"/>
+                          </a:solidFill>
+                          <a:effectLst/>
+                          <a:latin typeface="Calibri" panose="020F0502020204030204" pitchFamily="34" charset="0"/>
+                        </a:rPr>
+                        <a:t>LEFT SW</a:t>
+                      </a:r>
+                    </a:p>
+                  </a:txBody>
+                  <a:tcPr marL="7002" marR="7002" marT="0" marB="0" anchor="ctr"/>
+                </a:tc>
+                <a:tc>
+                  <a:txBody>
+                    <a:bodyPr/>
+                    <a:lstStyle/>
+                    <a:p>
+                      <a:pPr marL="108000" algn="l" rtl="0" fontAlgn="ctr">
+                        <a:spcBef>
+                          <a:spcPts val="0"/>
+                        </a:spcBef>
+                        <a:spcAft>
+                          <a:spcPts val="0"/>
+                        </a:spcAft>
+                      </a:pPr>
+                      <a:r>
+                        <a:rPr lang="de-DE" sz="900" b="0" i="0" u="none" strike="noStrike">
+                          <a:solidFill>
+                            <a:srgbClr val="000000"/>
+                          </a:solidFill>
+                          <a:effectLst/>
+                          <a:latin typeface="Calibri" panose="020F0502020204030204" pitchFamily="34" charset="0"/>
+                        </a:rPr>
+                        <a:t>GPIO 33</a:t>
+                      </a:r>
+                    </a:p>
+                  </a:txBody>
+                  <a:tcPr marL="7002" marR="7002" marT="0" marB="0" anchor="ctr"/>
+                </a:tc>
+                <a:tc>
+                  <a:txBody>
+                    <a:bodyPr/>
+                    <a:lstStyle/>
+                    <a:p>
+                      <a:pPr marL="108000" marR="0" lvl="0" indent="0" algn="l" defTabSz="914400" rtl="0" eaLnBrk="1" fontAlgn="ctr" latinLnBrk="0" hangingPunct="1">
+                        <a:lnSpc>
+                          <a:spcPct val="100000"/>
+                        </a:lnSpc>
+                        <a:spcBef>
+                          <a:spcPts val="0"/>
+                        </a:spcBef>
+                        <a:spcAft>
+                          <a:spcPts val="0"/>
+                        </a:spcAft>
+                        <a:buClrTx/>
+                        <a:buSzTx/>
+                        <a:buFontTx/>
+                        <a:buNone/>
+                        <a:tabLst/>
+                        <a:defRPr/>
+                      </a:pPr>
+                      <a:r>
+                        <a:rPr lang="de-DE" sz="900" b="0" i="0" u="none" strike="noStrike">
+                          <a:solidFill>
+                            <a:srgbClr val="000000"/>
+                          </a:solidFill>
+                          <a:effectLst/>
+                          <a:latin typeface="Calibri" panose="020F0502020204030204" pitchFamily="34" charset="0"/>
+                        </a:rPr>
+                        <a:t>SW at Rotary Encoder on left side</a:t>
+                      </a:r>
+                    </a:p>
+                  </a:txBody>
+                  <a:tcPr marL="7002" marR="7002" marT="0" marB="0" anchor="ctr"/>
+                </a:tc>
+                <a:extLst>
+                  <a:ext uri="{0D108BD9-81ED-4DB2-BD59-A6C34878D82A}">
+                    <a16:rowId xmlns:a16="http://schemas.microsoft.com/office/drawing/2014/main" val="3877505065"/>
+                  </a:ext>
+                </a:extLst>
+              </a:tr>
+              <a:tr h="219491">
                 <a:tc>
                   <a:txBody>
                     <a:bodyPr/>
@@ -25184,7 +25353,7 @@
                   </a:ext>
                 </a:extLst>
               </a:tr>
-              <a:tr h="226758">
+              <a:tr h="219491">
                 <a:tc>
                   <a:txBody>
                     <a:bodyPr/>
@@ -25296,7 +25465,7 @@
                   </a:ext>
                 </a:extLst>
               </a:tr>
-              <a:tr h="226758">
+              <a:tr h="219491">
                 <a:tc>
                   <a:txBody>
                     <a:bodyPr/>

</xml_diff>